<commit_message>
PWA: manifest, service worker, banner de instalação
</commit_message>
<xml_diff>
--- a/docs/Manual-Usuario.pptx
+++ b/docs/Manual-Usuario.pptx
@@ -3290,7 +3290,7 @@
                 <a:ea typeface="Calibri" pitchFamily="34" charset="-122"/>
                 <a:cs typeface="Calibri" pitchFamily="34" charset="-120"/>
               </a:rPr>
-              <a:t> </a:t>
+              <a:t xml:space="preserve"> </a:t>
             </a:r>
             <a:endParaRPr lang="en-US" sz="1200" dirty="0"/>
           </a:p>
@@ -3341,7 +3341,7 @@
                 <a:ea typeface="Calibri" pitchFamily="34" charset="-122"/>
                 <a:cs typeface="Calibri" pitchFamily="34" charset="-120"/>
               </a:rPr>
-              <a:t> </a:t>
+              <a:t xml:space="preserve"> </a:t>
             </a:r>
             <a:endParaRPr lang="en-US" sz="1200" dirty="0"/>
           </a:p>
@@ -9271,7 +9271,7 @@
                 <a:ea typeface="Calibri" pitchFamily="34" charset="-122"/>
                 <a:cs typeface="Calibri" pitchFamily="34" charset="-120"/>
               </a:rPr>
-              <a:t>Como Acessar o Sistema</a:t>
+              <a:t>Como Baixar e Instalar o App</a:t>
             </a:r>
             <a:endParaRPr lang="en-US" sz="2600" dirty="0"/>
           </a:p>
@@ -9349,11 +9349,11 @@
             <a:avLst/>
           </a:prstGeom>
           <a:solidFill>
-            <a:srgbClr val="4F46E5"/>
-          </a:solidFill>
-          <a:ln w="12700">
-            <a:solidFill>
-              <a:srgbClr val="4F46E5"/>
+            <a:srgbClr val="22C55E"/>
+          </a:solidFill>
+          <a:ln w="12700">
+            <a:solidFill>
+              <a:srgbClr val="22C55E"/>
             </a:solidFill>
             <a:prstDash val="solid"/>
           </a:ln>
@@ -9392,7 +9392,7 @@
                 <a:ea typeface="Calibri" pitchFamily="34" charset="-122"/>
                 <a:cs typeface="Calibri" pitchFamily="34" charset="-120"/>
               </a:rPr>
-              <a:t>🌐  Pelo Navegador (Web)</a:t>
+              <a:t>🤖  Android</a:t>
             </a:r>
             <a:endParaRPr lang="en-US" sz="1500" dirty="0"/>
           </a:p>
@@ -9423,119 +9423,208 @@
               <a:buNone/>
             </a:pPr>
             <a:r>
-              <a:rPr lang="en-US" sz="1250" dirty="0">
+              <a:rPr lang="pt-BR" sz="1100" b="1" dirty="0">
                 <a:solidFill>
                   <a:srgbClr val="1E293B"/>
                 </a:solidFill>
                 <a:latin typeface="Calibri" pitchFamily="34" charset="0"/>
-                <a:ea typeface="Calibri" pitchFamily="34" charset="-122"/>
-                <a:cs typeface="Calibri" pitchFamily="34" charset="-120"/>
-              </a:rPr>
-              <a:t>Acesse pelo navegador em qualquer computador ou celular:</a:t>
-            </a:r>
-            <a:endParaRPr lang="en-US" sz="1250" dirty="0"/>
-          </a:p>
-          <a:p>
-            <a:pPr indent="0" marL="0">
-              <a:buNone/>
-            </a:pPr>
-            <a:r>
-              <a:rPr lang="en-US" sz="1250" dirty="0">
+              </a:rPr>
+              <a:t xml:space="preserve">1. </a:t>
+            </a:r>
+            <a:r>
+              <a:rPr lang="pt-BR" sz="1100" dirty="0">
                 <a:solidFill>
                   <a:srgbClr val="1E293B"/>
                 </a:solidFill>
                 <a:latin typeface="Calibri" pitchFamily="34" charset="0"/>
-                <a:ea typeface="Calibri" pitchFamily="34" charset="-122"/>
-                <a:cs typeface="Calibri" pitchFamily="34" charset="-120"/>
-              </a:rPr>
-              <a:t> </a:t>
-            </a:r>
-            <a:endParaRPr lang="en-US" sz="1250" dirty="0"/>
-          </a:p>
-          <a:p>
-            <a:pPr indent="0" marL="0">
-              <a:buNone/>
-            </a:pPr>
-            <a:r>
-              <a:rPr lang="en-US" sz="1250" b="1" dirty="0">
-                <a:solidFill>
-                  <a:srgbClr val="4F46E5"/>
-                </a:solidFill>
-                <a:latin typeface="Calibri" pitchFamily="34" charset="0"/>
-                <a:ea typeface="Calibri" pitchFamily="34" charset="-122"/>
-                <a:cs typeface="Calibri" pitchFamily="34" charset="-120"/>
-              </a:rPr>
-              <a:t>rede-servicos.web.app</a:t>
-            </a:r>
-            <a:endParaRPr lang="en-US" sz="1250" dirty="0"/>
-          </a:p>
-          <a:p>
-            <a:pPr indent="0" marL="0">
-              <a:buNone/>
-            </a:pPr>
-            <a:r>
-              <a:rPr lang="en-US" sz="1250" dirty="0">
+              </a:rPr>
+              <a:t>Acesse rede-servicos.web.app pelo celular</a:t>
+            </a:r>
+          </a:p>
+          <a:p>
+            <a:pPr indent="0" marL="0">
+              <a:buNone/>
+            </a:pPr>
+            <a:r>
+              <a:rPr lang="pt-BR" sz="300" dirty="0">
                 <a:solidFill>
                   <a:srgbClr val="1E293B"/>
                 </a:solidFill>
                 <a:latin typeface="Calibri" pitchFamily="34" charset="0"/>
-                <a:ea typeface="Calibri" pitchFamily="34" charset="-122"/>
-                <a:cs typeface="Calibri" pitchFamily="34" charset="-120"/>
-              </a:rPr>
-              <a:t> </a:t>
-            </a:r>
-            <a:endParaRPr lang="en-US" sz="1250" dirty="0"/>
-          </a:p>
-          <a:p>
-            <a:pPr indent="0" marL="0">
-              <a:buNone/>
-            </a:pPr>
-            <a:r>
-              <a:rPr lang="en-US" sz="1250" dirty="0">
+              </a:rPr>
+              <a:t xml:space="preserve"> </a:t>
+            </a:r>
+          </a:p>
+          <a:p>
+            <a:pPr indent="0" marL="0">
+              <a:buNone/>
+            </a:pPr>
+            <a:r>
+              <a:rPr lang="pt-BR" sz="1100" b="1" dirty="0">
                 <a:solidFill>
                   <a:srgbClr val="1E293B"/>
                 </a:solidFill>
                 <a:latin typeface="Calibri" pitchFamily="34" charset="0"/>
-                <a:ea typeface="Calibri" pitchFamily="34" charset="-122"/>
-                <a:cs typeface="Calibri" pitchFamily="34" charset="-120"/>
-              </a:rPr>
-              <a:t>✅  Não precisa instalar nada</a:t>
-            </a:r>
-            <a:endParaRPr lang="en-US" sz="1250" dirty="0"/>
-          </a:p>
-          <a:p>
-            <a:pPr indent="0" marL="0">
-              <a:buNone/>
-            </a:pPr>
-            <a:r>
-              <a:rPr lang="en-US" sz="1250" dirty="0">
+              </a:rPr>
+              <a:t xml:space="preserve">2. </a:t>
+            </a:r>
+            <a:r>
+              <a:rPr lang="pt-BR" sz="1100" dirty="0">
                 <a:solidFill>
                   <a:srgbClr val="1E293B"/>
                 </a:solidFill>
                 <a:latin typeface="Calibri" pitchFamily="34" charset="0"/>
-                <a:ea typeface="Calibri" pitchFamily="34" charset="-122"/>
-                <a:cs typeface="Calibri" pitchFamily="34" charset="-120"/>
-              </a:rPr>
-              <a:t>✅  Funciona no Chrome, Edge, Firefox e Safari</a:t>
-            </a:r>
-            <a:endParaRPr lang="en-US" sz="1250" dirty="0"/>
-          </a:p>
-          <a:p>
-            <a:pPr indent="0" marL="0">
-              <a:buNone/>
-            </a:pPr>
-            <a:r>
-              <a:rPr lang="en-US" sz="1250" dirty="0">
+              </a:rPr>
+              <a:t>Toque em "Baixar APK - Android"</a:t>
+            </a:r>
+          </a:p>
+          <a:p>
+            <a:pPr indent="0" marL="0">
+              <a:buNone/>
+            </a:pPr>
+            <a:r>
+              <a:rPr lang="pt-BR" sz="300" dirty="0">
                 <a:solidFill>
                   <a:srgbClr val="1E293B"/>
                 </a:solidFill>
                 <a:latin typeface="Calibri" pitchFamily="34" charset="0"/>
-                <a:ea typeface="Calibri" pitchFamily="34" charset="-122"/>
-                <a:cs typeface="Calibri" pitchFamily="34" charset="-120"/>
-              </a:rPr>
-              <a:t>✅  Compatível com computador e celular</a:t>
-            </a:r>
-            <a:endParaRPr lang="en-US" sz="1250" dirty="0"/>
+              </a:rPr>
+              <a:t xml:space="preserve"> </a:t>
+            </a:r>
+          </a:p>
+          <a:p>
+            <a:pPr indent="0" marL="0">
+              <a:buNone/>
+            </a:pPr>
+            <a:r>
+              <a:rPr lang="pt-BR" sz="1100" b="1" dirty="0">
+                <a:solidFill>
+                  <a:srgbClr val="1E293B"/>
+                </a:solidFill>
+                <a:latin typeface="Calibri" pitchFamily="34" charset="0"/>
+              </a:rPr>
+              <a:t xml:space="preserve">3. </a:t>
+            </a:r>
+            <a:r>
+              <a:rPr lang="pt-BR" sz="1100" dirty="0">
+                <a:solidFill>
+                  <a:srgbClr val="1E293B"/>
+                </a:solidFill>
+                <a:latin typeface="Calibri" pitchFamily="34" charset="0"/>
+              </a:rPr>
+              <a:t>Abra o arquivo baixado na notificacao</a:t>
+            </a:r>
+          </a:p>
+          <a:p>
+            <a:pPr indent="0" marL="0">
+              <a:buNone/>
+            </a:pPr>
+            <a:r>
+              <a:rPr lang="pt-BR" sz="300" dirty="0">
+                <a:solidFill>
+                  <a:srgbClr val="1E293B"/>
+                </a:solidFill>
+                <a:latin typeface="Calibri" pitchFamily="34" charset="0"/>
+              </a:rPr>
+              <a:t xml:space="preserve"> </a:t>
+            </a:r>
+          </a:p>
+          <a:p>
+            <a:pPr indent="0" marL="0">
+              <a:buNone/>
+            </a:pPr>
+            <a:r>
+              <a:rPr lang="pt-BR" sz="1100" b="1" dirty="0">
+                <a:solidFill>
+                  <a:srgbClr val="1E293B"/>
+                </a:solidFill>
+                <a:latin typeface="Calibri" pitchFamily="34" charset="0"/>
+              </a:rPr>
+              <a:t xml:space="preserve">4. </a:t>
+            </a:r>
+            <a:r>
+              <a:rPr lang="pt-BR" sz="1100" dirty="0">
+                <a:solidFill>
+                  <a:srgbClr val="1E293B"/>
+                </a:solidFill>
+                <a:latin typeface="Calibri" pitchFamily="34" charset="0"/>
+              </a:rPr>
+              <a:t>Se aparecer aviso, ative "Instalar apps desconhecidos"</a:t>
+            </a:r>
+          </a:p>
+          <a:p>
+            <a:pPr indent="0" marL="0">
+              <a:buNone/>
+            </a:pPr>
+            <a:r>
+              <a:rPr lang="pt-BR" sz="300" dirty="0">
+                <a:solidFill>
+                  <a:srgbClr val="1E293B"/>
+                </a:solidFill>
+                <a:latin typeface="Calibri" pitchFamily="34" charset="0"/>
+              </a:rPr>
+              <a:t xml:space="preserve"> </a:t>
+            </a:r>
+          </a:p>
+          <a:p>
+            <a:pPr indent="0" marL="0">
+              <a:buNone/>
+            </a:pPr>
+            <a:r>
+              <a:rPr lang="pt-BR" sz="1100" b="1" dirty="0">
+                <a:solidFill>
+                  <a:srgbClr val="1E293B"/>
+                </a:solidFill>
+                <a:latin typeface="Calibri" pitchFamily="34" charset="0"/>
+              </a:rPr>
+              <a:t xml:space="preserve">5. </a:t>
+            </a:r>
+            <a:r>
+              <a:rPr lang="pt-BR" sz="1100" dirty="0">
+                <a:solidFill>
+                  <a:srgbClr val="1E293B"/>
+                </a:solidFill>
+                <a:latin typeface="Calibri" pitchFamily="34" charset="0"/>
+              </a:rPr>
+              <a:t>Volte e toque em "Instalar"</a:t>
+            </a:r>
+          </a:p>
+          <a:p>
+            <a:pPr indent="0" marL="0">
+              <a:buNone/>
+            </a:pPr>
+            <a:r>
+              <a:rPr lang="pt-BR" sz="300" dirty="0">
+                <a:solidFill>
+                  <a:srgbClr val="1E293B"/>
+                </a:solidFill>
+                <a:latin typeface="Calibri" pitchFamily="34" charset="0"/>
+              </a:rPr>
+              <a:t xml:space="preserve"> </a:t>
+            </a:r>
+          </a:p>
+          <a:p>
+            <a:pPr indent="0" marL="0">
+              <a:buNone/>
+            </a:pPr>
+            <a:r>
+              <a:rPr lang="pt-BR" sz="1100" b="1" dirty="0">
+                <a:solidFill>
+                  <a:srgbClr val="1E293B"/>
+                </a:solidFill>
+                <a:latin typeface="Calibri" pitchFamily="34" charset="0"/>
+              </a:rPr>
+              <a:t xml:space="preserve">6. </a:t>
+            </a:r>
+            <a:r>
+              <a:rPr lang="pt-BR" sz="1100" dirty="0">
+                <a:solidFill>
+                  <a:srgbClr val="1E293B"/>
+                </a:solidFill>
+                <a:latin typeface="Calibri" pitchFamily="34" charset="0"/>
+              </a:rPr>
+              <a:t>Pronto! Abra pelo icone na tela inicial</a:t>
+            </a:r>
           </a:p>
         </p:txBody>
       </p:sp>
@@ -9629,7 +9718,7 @@
                 <a:ea typeface="Calibri" pitchFamily="34" charset="-122"/>
                 <a:cs typeface="Calibri" pitchFamily="34" charset="-120"/>
               </a:rPr>
-              <a:t>📱  Pelo Celular (Mobile)</a:t>
+              <a:t>🍎  iPhone</a:t>
             </a:r>
             <a:endParaRPr lang="en-US" sz="1500" dirty="0"/>
           </a:p>
@@ -9660,102 +9749,250 @@
               <a:buNone/>
             </a:pPr>
             <a:r>
-              <a:rPr lang="en-US" sz="1250" dirty="0">
+              <a:rPr lang="pt-BR" sz="1100" b="1" dirty="0">
                 <a:solidFill>
                   <a:srgbClr val="1E293B"/>
                 </a:solidFill>
                 <a:latin typeface="Calibri" pitchFamily="34" charset="0"/>
-                <a:ea typeface="Calibri" pitchFamily="34" charset="-122"/>
-                <a:cs typeface="Calibri" pitchFamily="34" charset="-120"/>
-              </a:rPr>
-              <a:t>Instale o app Expo Go no seu celular:</a:t>
-            </a:r>
-            <a:endParaRPr lang="en-US" sz="1250" dirty="0"/>
-          </a:p>
-          <a:p>
-            <a:pPr indent="0" marL="0">
-              <a:buNone/>
-            </a:pPr>
-            <a:r>
-              <a:rPr lang="en-US" sz="1250" dirty="0">
+              </a:rPr>
+              <a:t xml:space="preserve">1. </a:t>
+            </a:r>
+            <a:r>
+              <a:rPr lang="pt-BR" sz="1100" dirty="0">
                 <a:solidFill>
                   <a:srgbClr val="1E293B"/>
                 </a:solidFill>
                 <a:latin typeface="Calibri" pitchFamily="34" charset="0"/>
-                <a:ea typeface="Calibri" pitchFamily="34" charset="-122"/>
-                <a:cs typeface="Calibri" pitchFamily="34" charset="-120"/>
-              </a:rPr>
-              <a:t> </a:t>
-            </a:r>
-            <a:endParaRPr lang="en-US" sz="1250" dirty="0"/>
-          </a:p>
-          <a:p>
-            <a:pPr indent="0" marL="0">
-              <a:buNone/>
-            </a:pPr>
-            <a:r>
-              <a:rPr lang="en-US" sz="1250" dirty="0">
+              </a:rPr>
+              <a:t>Acesse rede-servicos.web.app pelo celular</a:t>
+            </a:r>
+          </a:p>
+          <a:p>
+            <a:pPr indent="0" marL="0">
+              <a:buNone/>
+            </a:pPr>
+            <a:r>
+              <a:rPr lang="pt-BR" sz="300" dirty="0">
                 <a:solidFill>
                   <a:srgbClr val="1E293B"/>
                 </a:solidFill>
                 <a:latin typeface="Calibri" pitchFamily="34" charset="0"/>
-                <a:ea typeface="Calibri" pitchFamily="34" charset="-122"/>
-                <a:cs typeface="Calibri" pitchFamily="34" charset="-120"/>
-              </a:rPr>
-              <a:t>📥  App Store (iPhone)</a:t>
-            </a:r>
-            <a:endParaRPr lang="en-US" sz="1250" dirty="0"/>
-          </a:p>
-          <a:p>
-            <a:pPr indent="0" marL="0">
-              <a:buNone/>
-            </a:pPr>
-            <a:r>
-              <a:rPr lang="en-US" sz="1250" dirty="0">
+              </a:rPr>
+              <a:t xml:space="preserve"> </a:t>
+            </a:r>
+          </a:p>
+          <a:p>
+            <a:pPr indent="0" marL="0">
+              <a:buNone/>
+            </a:pPr>
+            <a:r>
+              <a:rPr lang="pt-BR" sz="1100" b="1" dirty="0">
                 <a:solidFill>
                   <a:srgbClr val="1E293B"/>
                 </a:solidFill>
                 <a:latin typeface="Calibri" pitchFamily="34" charset="0"/>
-                <a:ea typeface="Calibri" pitchFamily="34" charset="-122"/>
-                <a:cs typeface="Calibri" pitchFamily="34" charset="-120"/>
-              </a:rPr>
-              <a:t>📥  Play Store (Android)</a:t>
-            </a:r>
-            <a:endParaRPr lang="en-US" sz="1250" dirty="0"/>
-          </a:p>
-          <a:p>
-            <a:pPr indent="0" marL="0">
-              <a:buNone/>
-            </a:pPr>
-            <a:r>
-              <a:rPr lang="en-US" sz="1250" dirty="0">
+              </a:rPr>
+              <a:t xml:space="preserve">2. </a:t>
+            </a:r>
+            <a:r>
+              <a:rPr lang="pt-BR" sz="1100" dirty="0">
                 <a:solidFill>
                   <a:srgbClr val="1E293B"/>
                 </a:solidFill>
                 <a:latin typeface="Calibri" pitchFamily="34" charset="0"/>
-                <a:ea typeface="Calibri" pitchFamily="34" charset="-122"/>
-                <a:cs typeface="Calibri" pitchFamily="34" charset="-120"/>
-              </a:rPr>
-              <a:t> </a:t>
-            </a:r>
-            <a:endParaRPr lang="en-US" sz="1250" dirty="0"/>
-          </a:p>
-          <a:p>
-            <a:pPr indent="0" marL="0">
-              <a:buNone/>
-            </a:pPr>
-            <a:r>
-              <a:rPr lang="en-US" sz="1250" dirty="0">
+              </a:rPr>
+              <a:t>Toque em "1. Instalar Expo Go" e baixe da App Store</a:t>
+            </a:r>
+          </a:p>
+          <a:p>
+            <a:pPr indent="0" marL="0">
+              <a:buNone/>
+            </a:pPr>
+            <a:r>
+              <a:rPr lang="pt-BR" sz="300" dirty="0">
                 <a:solidFill>
                   <a:srgbClr val="1E293B"/>
                 </a:solidFill>
                 <a:latin typeface="Calibri" pitchFamily="34" charset="0"/>
-                <a:ea typeface="Calibri" pitchFamily="34" charset="-122"/>
-                <a:cs typeface="Calibri" pitchFamily="34" charset="-120"/>
-              </a:rPr>
-              <a:t>Depois escaneie o QR Code para acessar.</a:t>
-            </a:r>
-            <a:endParaRPr lang="en-US" sz="1250" dirty="0"/>
+              </a:rPr>
+              <a:t xml:space="preserve"> </a:t>
+            </a:r>
+          </a:p>
+          <a:p>
+            <a:pPr indent="0" marL="0">
+              <a:buNone/>
+            </a:pPr>
+            <a:r>
+              <a:rPr lang="pt-BR" sz="1100" b="1" dirty="0">
+                <a:solidFill>
+                  <a:srgbClr val="1E293B"/>
+                </a:solidFill>
+                <a:latin typeface="Calibri" pitchFamily="34" charset="0"/>
+              </a:rPr>
+              <a:t xml:space="preserve">3. </a:t>
+            </a:r>
+            <a:r>
+              <a:rPr lang="pt-BR" sz="1100" dirty="0">
+                <a:solidFill>
+                  <a:srgbClr val="1E293B"/>
+                </a:solidFill>
+                <a:latin typeface="Calibri" pitchFamily="34" charset="0"/>
+              </a:rPr>
+              <a:t>Apos instalar o Expo Go, volte ao site</a:t>
+            </a:r>
+          </a:p>
+          <a:p>
+            <a:pPr indent="0" marL="0">
+              <a:buNone/>
+            </a:pPr>
+            <a:r>
+              <a:rPr lang="pt-BR" sz="300" dirty="0">
+                <a:solidFill>
+                  <a:srgbClr val="1E293B"/>
+                </a:solidFill>
+                <a:latin typeface="Calibri" pitchFamily="34" charset="0"/>
+              </a:rPr>
+              <a:t xml:space="preserve"> </a:t>
+            </a:r>
+          </a:p>
+          <a:p>
+            <a:pPr indent="0" marL="0">
+              <a:buNone/>
+            </a:pPr>
+            <a:r>
+              <a:rPr lang="pt-BR" sz="1100" b="1" dirty="0">
+                <a:solidFill>
+                  <a:srgbClr val="1E293B"/>
+                </a:solidFill>
+                <a:latin typeface="Calibri" pitchFamily="34" charset="0"/>
+              </a:rPr>
+              <a:t xml:space="preserve">4. </a:t>
+            </a:r>
+            <a:r>
+              <a:rPr lang="pt-BR" sz="1100" dirty="0">
+                <a:solidFill>
+                  <a:srgbClr val="1E293B"/>
+                </a:solidFill>
+                <a:latin typeface="Calibri" pitchFamily="34" charset="0"/>
+              </a:rPr>
+              <a:t>Toque em "2. Abrir o App"</a:t>
+            </a:r>
+          </a:p>
+          <a:p>
+            <a:pPr indent="0" marL="0">
+              <a:buNone/>
+            </a:pPr>
+            <a:r>
+              <a:rPr lang="pt-BR" sz="300" dirty="0">
+                <a:solidFill>
+                  <a:srgbClr val="1E293B"/>
+                </a:solidFill>
+                <a:latin typeface="Calibri" pitchFamily="34" charset="0"/>
+              </a:rPr>
+              <a:t xml:space="preserve"> </a:t>
+            </a:r>
+          </a:p>
+          <a:p>
+            <a:pPr indent="0" marL="0">
+              <a:buNone/>
+            </a:pPr>
+            <a:r>
+              <a:rPr lang="pt-BR" sz="1100" b="1" dirty="0">
+                <a:solidFill>
+                  <a:srgbClr val="1E293B"/>
+                </a:solidFill>
+                <a:latin typeface="Calibri" pitchFamily="34" charset="0"/>
+              </a:rPr>
+              <a:t xml:space="preserve">5. </a:t>
+            </a:r>
+            <a:r>
+              <a:rPr lang="pt-BR" sz="1100" dirty="0">
+                <a:solidFill>
+                  <a:srgbClr val="1E293B"/>
+                </a:solidFill>
+                <a:latin typeface="Calibri" pitchFamily="34" charset="0"/>
+              </a:rPr>
+              <a:t>O Expo Go abrira com o app automaticamente</a:t>
+            </a:r>
+          </a:p>
+          <a:p>
+            <a:pPr indent="0" marL="0">
+              <a:buNone/>
+            </a:pPr>
+            <a:r>
+              <a:rPr lang="pt-BR" sz="300" dirty="0">
+                <a:solidFill>
+                  <a:srgbClr val="1E293B"/>
+                </a:solidFill>
+                <a:latin typeface="Calibri" pitchFamily="34" charset="0"/>
+              </a:rPr>
+              <a:t xml:space="preserve"> </a:t>
+            </a:r>
+          </a:p>
+          <a:p>
+            <a:pPr indent="0" marL="0">
+              <a:buNone/>
+            </a:pPr>
+            <a:r>
+              <a:rPr lang="pt-BR" sz="1100" b="1" dirty="0">
+                <a:solidFill>
+                  <a:srgbClr val="1E293B"/>
+                </a:solidFill>
+                <a:latin typeface="Calibri" pitchFamily="34" charset="0"/>
+              </a:rPr>
+              <a:t xml:space="preserve">6. </a:t>
+            </a:r>
+            <a:r>
+              <a:rPr lang="pt-BR" sz="1100" dirty="0">
+                <a:solidFill>
+                  <a:srgbClr val="1E293B"/>
+                </a:solidFill>
+                <a:latin typeface="Calibri" pitchFamily="34" charset="0"/>
+              </a:rPr>
+              <a:t>Pronto! O app ja estara disponivel</a:t>
+            </a:r>
+          </a:p>
+        </p:txBody>
+      </p:sp>
+      <p:sp>
+        <p:nvSpPr>
+          <p:cNvPr id="20" name="Text Footer"/>
+          <p:cNvSpPr/>
+          <p:nvPr/>
+        </p:nvSpPr>
+        <p:spPr>
+          <a:xfrm>
+            <a:off x="365760" y="4617600"/>
+            <a:ext cx="8412480" cy="330000"/>
+          </a:xfrm>
+          <a:prstGeom prst="rect">
+            <a:avLst/>
+          </a:prstGeom>
+          <a:solidFill>
+            <a:srgbClr val="FEF9C3"/>
+          </a:solidFill>
+          <a:ln w="12700">
+            <a:solidFill>
+              <a:srgbClr val="EAB308"/>
+            </a:solidFill>
+          </a:ln>
+        </p:spPr>
+        <p:txBody>
+          <a:bodyPr wrap="square" lIns="91440" tIns="45720" rIns="91440" bIns="45720" rtlCol="0" anchor="ctr"/>
+          <a:lstStyle/>
+          <a:p>
+            <a:pPr indent="0" marL="0">
+              <a:buNone/>
+            </a:pPr>
+            <a:r>
+              <a:rPr lang="pt-BR" sz="1000" b="1" dirty="0">
+                <a:solidFill>
+                  <a:srgbClr val="92400E"/>
+                </a:solidFill>
+                <a:latin typeface="Calibri" pitchFamily="34" charset="0"/>
+              </a:rPr>
+              <a:t>No Android, o sistema pode pedir permissao para instalar apps de fontes externas - isso e normal e seguro.</a:t>
+            </a:r>
           </a:p>
         </p:txBody>
       </p:sp>
@@ -14443,7 +14680,7 @@
                 <a:ea typeface="Calibri" pitchFamily="34" charset="-122"/>
                 <a:cs typeface="Calibri" pitchFamily="34" charset="-120"/>
               </a:rPr>
-              <a:t> </a:t>
+              <a:t xml:space="preserve"> </a:t>
             </a:r>
             <a:endParaRPr lang="en-US" sz="1200" dirty="0"/>
           </a:p>

</xml_diff>

<commit_message>
feat: redirecionar ao entrar em comunidade e mostrar lista de membros
</commit_message>
<xml_diff>
--- a/docs/Manual-Usuario.pptx
+++ b/docs/Manual-Usuario.pptx
@@ -9271,7 +9271,7 @@
                 <a:ea typeface="Calibri" pitchFamily="34" charset="-122"/>
                 <a:cs typeface="Calibri" pitchFamily="34" charset="-120"/>
               </a:rPr>
-              <a:t>Como Baixar e Instalar o App</a:t>
+              <a:t>Como Acessar o Sistema</a:t>
             </a:r>
             <a:endParaRPr lang="en-US" sz="2600" dirty="0"/>
           </a:p>
@@ -9392,7 +9392,7 @@
                 <a:ea typeface="Calibri" pitchFamily="34" charset="-122"/>
                 <a:cs typeface="Calibri" pitchFamily="34" charset="-120"/>
               </a:rPr>
-              <a:t>🤖  Android</a:t>
+              <a:t>🤖  Android (Chrome)</a:t>
             </a:r>
             <a:endParaRPr lang="en-US" sz="1500" dirty="0"/>
           </a:p>
@@ -9438,7 +9438,7 @@
                 </a:solidFill>
                 <a:latin typeface="Calibri" pitchFamily="34" charset="0"/>
               </a:rPr>
-              <a:t>Acesse rede-servicos.web.app pelo celular</a:t>
+              <a:t>Abra o Chrome e acesse rede-servicos.web.app</a:t>
             </a:r>
           </a:p>
           <a:p>
@@ -9475,7 +9475,7 @@
                 </a:solidFill>
                 <a:latin typeface="Calibri" pitchFamily="34" charset="0"/>
               </a:rPr>
-              <a:t>Toque em "Baixar APK - Android"</a:t>
+              <a:t>Toque nos tres pontos (⋮) no canto superior direito</a:t>
             </a:r>
           </a:p>
           <a:p>
@@ -9512,7 +9512,7 @@
                 </a:solidFill>
                 <a:latin typeface="Calibri" pitchFamily="34" charset="0"/>
               </a:rPr>
-              <a:t>Abra o arquivo baixado na notificacao</a:t>
+              <a:t>Toque em "Adicionar a tela inicial"</a:t>
             </a:r>
           </a:p>
           <a:p>
@@ -9549,7 +9549,7 @@
                 </a:solidFill>
                 <a:latin typeface="Calibri" pitchFamily="34" charset="0"/>
               </a:rPr>
-              <a:t>Se aparecer aviso, ative "Instalar apps desconhecidos"</a:t>
+              <a:t>Confirme tocando em "Adicionar"</a:t>
             </a:r>
           </a:p>
           <a:p>
@@ -9586,7 +9586,7 @@
                 </a:solidFill>
                 <a:latin typeface="Calibri" pitchFamily="34" charset="0"/>
               </a:rPr>
-              <a:t>Volte e toque em "Instalar"</a:t>
+              <a:t>Pronto! O icone aparece na tela inicial do celular</a:t>
             </a:r>
           </a:p>
           <a:p>
@@ -9623,7 +9623,7 @@
                 </a:solidFill>
                 <a:latin typeface="Calibri" pitchFamily="34" charset="0"/>
               </a:rPr>
-              <a:t>Pronto! Abra pelo icone na tela inicial</a:t>
+              <a:t>Abre igual a um app — sem precisar do navegador!</a:t>
             </a:r>
           </a:p>
         </p:txBody>
@@ -9718,7 +9718,7 @@
                 <a:ea typeface="Calibri" pitchFamily="34" charset="-122"/>
                 <a:cs typeface="Calibri" pitchFamily="34" charset="-120"/>
               </a:rPr>
-              <a:t>🍎  iPhone</a:t>
+              <a:t>🍎  iPhone (Safari)</a:t>
             </a:r>
             <a:endParaRPr lang="en-US" sz="1500" dirty="0"/>
           </a:p>
@@ -9764,7 +9764,7 @@
                 </a:solidFill>
                 <a:latin typeface="Calibri" pitchFamily="34" charset="0"/>
               </a:rPr>
-              <a:t>Acesse rede-servicos.web.app pelo celular</a:t>
+              <a:t>Abra o Safari e acesse rede-servicos.web.app</a:t>
             </a:r>
           </a:p>
           <a:p>
@@ -9801,7 +9801,7 @@
                 </a:solidFill>
                 <a:latin typeface="Calibri" pitchFamily="34" charset="0"/>
               </a:rPr>
-              <a:t>Toque em "1. Instalar Expo Go" e baixe da App Store</a:t>
+              <a:t>Toque no icone Compartilhar (quadrado com seta)</a:t>
             </a:r>
           </a:p>
           <a:p>
@@ -9838,7 +9838,7 @@
                 </a:solidFill>
                 <a:latin typeface="Calibri" pitchFamily="34" charset="0"/>
               </a:rPr>
-              <a:t>Apos instalar o Expo Go, volte ao site</a:t>
+              <a:t>Toque em "Adicionar a Tela de Inicio"</a:t>
             </a:r>
           </a:p>
           <a:p>
@@ -9875,7 +9875,7 @@
                 </a:solidFill>
                 <a:latin typeface="Calibri" pitchFamily="34" charset="0"/>
               </a:rPr>
-              <a:t>Toque em "2. Abrir o App"</a:t>
+              <a:t>Toque em "Adicionar" no canto superior direito</a:t>
             </a:r>
           </a:p>
           <a:p>
@@ -9912,7 +9912,7 @@
                 </a:solidFill>
                 <a:latin typeface="Calibri" pitchFamily="34" charset="0"/>
               </a:rPr>
-              <a:t>O Expo Go abrira com o app automaticamente</a:t>
+              <a:t>Pronto! O icone aparece na tela inicial do iPhone</a:t>
             </a:r>
           </a:p>
           <a:p>
@@ -9949,7 +9949,7 @@
                 </a:solidFill>
                 <a:latin typeface="Calibri" pitchFamily="34" charset="0"/>
               </a:rPr>
-              <a:t>Pronto! O app ja estara disponivel</a:t>
+              <a:t>Abre igual a um app — sem precisar do Safari!</a:t>
             </a:r>
           </a:p>
         </p:txBody>
@@ -9991,7 +9991,7 @@
                 </a:solidFill>
                 <a:latin typeface="Calibri" pitchFamily="34" charset="0"/>
               </a:rPr>
-              <a:t>No Android, o sistema pode pedir permissao para instalar apps de fontes externas - isso e normal e seguro.</a:t>
+              <a:t>Nao precisa baixar nada! O site funciona como um app diretamente no seu celular — rapido, seguro e sempre atualizado.</a:t>
             </a:r>
           </a:p>
         </p:txBody>

</xml_diff>